<commit_message>
Update Digital Marketing deck: remove Authorized Dealer references
Reframe dealer/location pages as campaign & product landing pages and
dealer assignment as sales-team assignment across all 5 slides; add the
deck to the README index.

Co-Authored-By: Claude Opus 4.8 <noreply@anthropic.com>
</commit_message>
<xml_diff>
--- a/FabLuxe_Digital_Marketing_Strategy.pptx
+++ b/FabLuxe_Digital_Marketing_Strategy.pptx
@@ -594,7 +594,7 @@
           <a:p>
             <a:r>
               <a:rPr lang="en-US" dirty="0"/>
-              <a:t>Slide 2: end-to-end funnel from traffic sources to conversion, via authorized dealer/location landing pages. Objective panel on the right; services strip at the bottom.</a:t>
+              <a:t>Slide 2: end-to-end funnel from traffic sources to conversion, via campaign &amp; product landing pages. Objective panel on the right; services strip at the bottom.</a:t>
             </a:r>
             <a:endParaRPr lang="en-US" dirty="0"/>
           </a:p>
@@ -682,7 +682,7 @@
           <a:p>
             <a:r>
               <a:rPr lang="en-US" dirty="0"/>
-              <a:t>Slide 3: nine services with the concrete deliverable for each — SEO, SEM, SMO/SMM, website, dealer/location landing pages, lead capture &amp; routing, email &amp; WhatsApp, creative, analytics.</a:t>
+              <a:t>Slide 3: nine services with the concrete deliverable for each — SEO, SEM, SMO/SMM, website, campaign landing pages, lead capture &amp; routing, email &amp; WhatsApp, creative, analytics.</a:t>
             </a:r>
             <a:endParaRPr lang="en-US" dirty="0"/>
           </a:p>
@@ -770,7 +770,7 @@
           <a:p>
             <a:r>
               <a:rPr lang="en-US" dirty="0"/>
-              <a:t>Slide 4: our approach (full-funnel, data-led, authorized &amp; on-brand, always optimizing), our delivery model (dedicated pod, weekly sprints, transparent reporting, tools, single POC, monthly review), and a clean You-provide / We-deliver split between One Global/Fab Luxe and the Digital Marketing Team.</a:t>
+              <a:t>Slide 4: our approach (full-funnel, data-led, conversion-focused, always optimizing), our delivery model (dedicated pod, weekly sprints, transparent reporting, tools, single POC, monthly review), and a clean You-provide / We-deliver split between One Global/Fab Luxe and the Digital Marketing Team.</a:t>
             </a:r>
             <a:endParaRPr lang="en-US" dirty="0"/>
           </a:p>
@@ -2417,7 +2417,7 @@
                 <a:ea typeface="Calibri" pitchFamily="34" charset="-122"/>
                 <a:cs typeface="Calibri" pitchFamily="34" charset="-120"/>
               </a:rPr>
-              <a:t>Authorized Dealer / Location Landing Pages</a:t>
+              <a:t>Campaign &amp; Product Landing Pages</a:t>
             </a:r>
             <a:endParaRPr lang="en-US" sz="1200" dirty="0"/>
           </a:p>
@@ -2753,7 +2753,7 @@
                 <a:ea typeface="Calibri" pitchFamily="34" charset="-122"/>
                 <a:cs typeface="Calibri" pitchFamily="34" charset="-120"/>
               </a:rPr>
-              <a:t>Dealer / Sales Assignment</a:t>
+              <a:t>Sales Team Assignment</a:t>
             </a:r>
             <a:endParaRPr lang="en-US" sz="1200" dirty="0"/>
           </a:p>
@@ -3343,7 +3343,7 @@
                 <a:ea typeface="Calibri" pitchFamily="34" charset="-122"/>
                 <a:cs typeface="Calibri" pitchFamily="34" charset="-120"/>
               </a:rPr>
-              <a:t>Assign to dealers → close → revenue &amp; ROI</a:t>
+              <a:t>Assign to sales → close → revenue &amp; ROI</a:t>
             </a:r>
             <a:endParaRPr lang="en-US" sz="1400" dirty="0"/>
           </a:p>
@@ -4637,7 +4637,7 @@
                 <a:ea typeface="Cambria" pitchFamily="34" charset="-122"/>
                 <a:cs typeface="Cambria" pitchFamily="34" charset="-120"/>
               </a:rPr>
-              <a:t>Dealer / Location Pages</a:t>
+              <a:t>Campaign Landing Pages</a:t>
             </a:r>
             <a:endParaRPr lang="en-US" sz="1450" dirty="0"/>
           </a:p>
@@ -4676,7 +4676,7 @@
                 <a:ea typeface="Calibri" pitchFamily="34" charset="-122"/>
                 <a:cs typeface="Calibri" pitchFamily="34" charset="-120"/>
               </a:rPr>
-              <a:t>Authorized pages · WhatsApp / Call CTAs</a:t>
+              <a:t>High-converting pages · WhatsApp / Call CTAs</a:t>
             </a:r>
             <a:endParaRPr lang="en-US" sz="1050" dirty="0"/>
           </a:p>
@@ -4852,7 +4852,7 @@
                 <a:ea typeface="Calibri" pitchFamily="34" charset="-122"/>
                 <a:cs typeface="Calibri" pitchFamily="34" charset="-120"/>
               </a:rPr>
-              <a:t>Forms → CRM → dealer assignment</a:t>
+              <a:t>Forms → CRM → sales assignment</a:t>
             </a:r>
             <a:endParaRPr lang="en-US" sz="1050" dirty="0"/>
           </a:p>
@@ -6054,7 +6054,7 @@
                 <a:ea typeface="Cambria" pitchFamily="34" charset="-122"/>
                 <a:cs typeface="Cambria" pitchFamily="34" charset="-120"/>
               </a:rPr>
-              <a:t>Authorized &amp; On-Brand</a:t>
+              <a:t>Conversion-Focused</a:t>
             </a:r>
             <a:endParaRPr lang="en-US" sz="1500" dirty="0"/>
           </a:p>
@@ -6096,7 +6096,7 @@
                 <a:ea typeface="Calibri" pitchFamily="34" charset="-122"/>
                 <a:cs typeface="Calibri" pitchFamily="34" charset="-120"/>
               </a:rPr>
-              <a:t>Official Fab Luxe dealer / location pages</a:t>
+              <a:t>Landing pages &amp; CTAs built to convert</a:t>
             </a:r>
             <a:endParaRPr lang="en-US" sz="1100" dirty="0"/>
           </a:p>
@@ -6604,7 +6604,7 @@
                 <a:ea typeface="Calibri" pitchFamily="34" charset="-122"/>
                 <a:cs typeface="Calibri" pitchFamily="34" charset="-120"/>
               </a:rPr>
-              <a:t>Product info &amp; dealer authorization</a:t>
+              <a:t>Product info &amp; content</a:t>
             </a:r>
             <a:endParaRPr lang="en-US" sz="1100" dirty="0"/>
           </a:p>
@@ -6650,7 +6650,7 @@
                 <a:ea typeface="Calibri" pitchFamily="34" charset="-122"/>
                 <a:cs typeface="Calibri" pitchFamily="34" charset="-120"/>
               </a:rPr>
-              <a:t>Sales team to assign &amp; close</a:t>
+              <a:t>Sales team to close leads</a:t>
             </a:r>
             <a:endParaRPr lang="en-US" sz="1100" dirty="0"/>
           </a:p>
@@ -7500,7 +7500,7 @@
                 <a:ea typeface="Calibri" pitchFamily="34" charset="-122"/>
                 <a:cs typeface="Calibri" pitchFamily="34" charset="-120"/>
               </a:rPr>
-              <a:t>Dealer mapping</a:t>
+              <a:t>Audience &amp; market mapping</a:t>
             </a:r>
             <a:endParaRPr lang="en-US" sz="1050" dirty="0"/>
           </a:p>

</xml_diff>

<commit_message>
Restructure timeline: pull Scale-up into Launch week, make Generate & Optimize continuous (Stay Market-Ready)
</commit_message>
<xml_diff>
--- a/FabLuxe_Digital_Marketing_Strategy.pptx
+++ b/FabLuxe_Digital_Marketing_Strategy.pptx
@@ -858,7 +858,7 @@
           <a:p>
             <a:r>
               <a:rPr lang="en-US" dirty="0"/>
-              <a:t>Slide 5: 90-day timeline — Plan &amp; Foundation (wk 1-2), Build &amp; Launch (wk 3-4), Generate &amp; Optimize (wk 5-8), Scale (wk 9-12), then ongoing growth. KPIs tracked weekly: traffic, leads, qualified leads, CPL, conversion rate, revenue, ROI.</a:t>
+              <a:t>Slide 5: fast-ramp timeline. Week 1 Plan &amp; Foundation; Week 2 Launch &amp; Scale (scale-up pulled forward into the launch week to cut time-to-scale); Week 3+ Generate &amp; Optimize continuously; then Ongoing — Stay Market-Ready, adjusting to real-estate cost shifts and attracting customers consistently. KPIs tracked weekly: traffic, leads, qualified leads, CPL, conversion rate, revenue, ROI.</a:t>
             </a:r>
             <a:endParaRPr lang="en-US" dirty="0"/>
           </a:p>
@@ -1960,7 +1960,7 @@
                 <a:ea typeface="Calibri" pitchFamily="34" charset="-122"/>
                 <a:cs typeface="Calibri" pitchFamily="34" charset="-120"/>
               </a:rPr>
-              <a:t>Services  ·  Our Approach  ·  Delivery Model  ·  90-Day Timeline</a:t>
+              <a:t>Services  ·  Our Approach  ·  Delivery Model  ·  Fast-Ramp Timeline</a:t>
             </a:r>
             <a:endParaRPr lang="en-US" sz="1150" dirty="0"/>
           </a:p>
@@ -7148,7 +7148,7 @@
                 <a:ea typeface="Calibri" pitchFamily="34" charset="-122"/>
                 <a:cs typeface="Calibri" pitchFamily="34" charset="-120"/>
               </a:rPr>
-              <a:t>HOW MUCH TIME</a:t>
+              <a:t>FAST-RAMP ROLLOUT</a:t>
             </a:r>
             <a:endParaRPr lang="en-US" sz="1150" dirty="0"/>
           </a:p>
@@ -7207,7 +7207,7 @@
                 <a:ea typeface="Cambria" pitchFamily="34" charset="-122"/>
                 <a:cs typeface="Cambria" pitchFamily="34" charset="-120"/>
               </a:rPr>
-              <a:t>90-Day Timeline &amp; KPIs</a:t>
+              <a:t>Timeline &amp; KPIs</a:t>
             </a:r>
             <a:endParaRPr lang="en-US" sz="3000" dirty="0"/>
           </a:p>
@@ -7367,7 +7367,7 @@
                 <a:ea typeface="Calibri" pitchFamily="34" charset="-122"/>
                 <a:cs typeface="Calibri" pitchFamily="34" charset="-120"/>
               </a:rPr>
-              <a:t>WEEKS 1–2</a:t>
+              <a:t>WEEK 1</a:t>
             </a:r>
             <a:endParaRPr lang="en-US" sz="1000" dirty="0"/>
           </a:p>
@@ -7685,7 +7685,7 @@
                 <a:ea typeface="Calibri" pitchFamily="34" charset="-122"/>
                 <a:cs typeface="Calibri" pitchFamily="34" charset="-120"/>
               </a:rPr>
-              <a:t>WEEKS 3–4</a:t>
+              <a:t>WEEK 2</a:t>
             </a:r>
             <a:endParaRPr lang="en-US" sz="1000" dirty="0"/>
           </a:p>
@@ -7724,7 +7724,7 @@
                 <a:ea typeface="Cambria" pitchFamily="34" charset="-122"/>
                 <a:cs typeface="Cambria" pitchFamily="34" charset="-120"/>
               </a:rPr>
-              <a:t>Build &amp; Launch</a:t>
+              <a:t>Launch &amp; Scale</a:t>
             </a:r>
             <a:endParaRPr lang="en-US" sz="1650" dirty="0"/>
           </a:p>
@@ -7818,7 +7818,7 @@
                 <a:ea typeface="Calibri" pitchFamily="34" charset="-122"/>
                 <a:cs typeface="Calibri" pitchFamily="34" charset="-120"/>
               </a:rPr>
-              <a:t>Social setup</a:t>
+              <a:t>Campaigns live: SEO/SEM/SMM</a:t>
             </a:r>
             <a:endParaRPr lang="en-US" sz="1050" dirty="0"/>
           </a:p>
@@ -7842,7 +7842,7 @@
                 <a:ea typeface="Calibri" pitchFamily="34" charset="-122"/>
                 <a:cs typeface="Calibri" pitchFamily="34" charset="-120"/>
               </a:rPr>
-              <a:t>Content &amp; creative</a:t>
+              <a:t>Scale winning pages fast</a:t>
             </a:r>
             <a:endParaRPr lang="en-US" sz="1050" dirty="0"/>
           </a:p>
@@ -7866,7 +7866,7 @@
                 <a:ea typeface="Calibri" pitchFamily="34" charset="-122"/>
                 <a:cs typeface="Calibri" pitchFamily="34" charset="-120"/>
               </a:rPr>
-              <a:t>Google Ads · WhatsApp / email</a:t>
+              <a:t>Expand channels &amp; budgets</a:t>
             </a:r>
             <a:endParaRPr lang="en-US" sz="1050" dirty="0"/>
           </a:p>
@@ -8003,7 +8003,7 @@
                 <a:ea typeface="Calibri" pitchFamily="34" charset="-122"/>
                 <a:cs typeface="Calibri" pitchFamily="34" charset="-120"/>
               </a:rPr>
-              <a:t>WEEKS 5–8</a:t>
+              <a:t>WEEK 3+</a:t>
             </a:r>
             <a:endParaRPr lang="en-US" sz="1000" dirty="0"/>
           </a:p>
@@ -8088,7 +8088,7 @@
                 <a:ea typeface="Calibri" pitchFamily="34" charset="-122"/>
                 <a:cs typeface="Calibri" pitchFamily="34" charset="-120"/>
               </a:rPr>
-              <a:t>Launch SEO / SEM / SMM</a:t>
+              <a:t>Continuous lead generation</a:t>
             </a:r>
             <a:endParaRPr lang="en-US" sz="1050" dirty="0"/>
           </a:p>
@@ -8112,7 +8112,7 @@
                 <a:ea typeface="Calibri" pitchFamily="34" charset="-122"/>
                 <a:cs typeface="Calibri" pitchFamily="34" charset="-120"/>
               </a:rPr>
-              <a:t>Social posting</a:t>
+              <a:t>Qualify &amp; assign leads</a:t>
             </a:r>
             <a:endParaRPr lang="en-US" sz="1050" dirty="0"/>
           </a:p>
@@ -8136,7 +8136,7 @@
                 <a:ea typeface="Calibri" pitchFamily="34" charset="-122"/>
                 <a:cs typeface="Calibri" pitchFamily="34" charset="-120"/>
               </a:rPr>
-              <a:t>Email / WhatsApp campaigns</a:t>
+              <a:t>Weekly optimization &amp; A/B tests</a:t>
             </a:r>
             <a:endParaRPr lang="en-US" sz="1050" dirty="0"/>
           </a:p>
@@ -8160,31 +8160,7 @@
                 <a:ea typeface="Calibri" pitchFamily="34" charset="-122"/>
                 <a:cs typeface="Calibri" pitchFamily="34" charset="-120"/>
               </a:rPr>
-              <a:t>Qualify &amp; assign leads</a:t>
-            </a:r>
-            <a:endParaRPr lang="en-US" sz="1050" dirty="0"/>
-          </a:p>
-          <a:p>
-            <a:pPr marL="152400" indent="-152400">
-              <a:lnSpc>
-                <a:spcPct val="100000"/>
-              </a:lnSpc>
-              <a:spcAft>
-                <a:spcPts val="600"/>
-              </a:spcAft>
-              <a:buSzPct val="100000"/>
-              <a:buChar char="•"/>
-            </a:pPr>
-            <a:r>
-              <a:rPr lang="en-US" sz="1050" dirty="0">
-                <a:solidFill>
-                  <a:srgbClr val="1A1E24"/>
-                </a:solidFill>
-                <a:latin typeface="Calibri" pitchFamily="34" charset="0"/>
-                <a:ea typeface="Calibri" pitchFamily="34" charset="-122"/>
-                <a:cs typeface="Calibri" pitchFamily="34" charset="-120"/>
-              </a:rPr>
-              <a:t>Weekly optimization</a:t>
+              <a:t>Track CPL, QL &amp; ROI</a:t>
             </a:r>
             <a:endParaRPr lang="en-US" sz="1050" dirty="0"/>
           </a:p>
@@ -8321,7 +8297,7 @@
                 <a:ea typeface="Calibri" pitchFamily="34" charset="-122"/>
                 <a:cs typeface="Calibri" pitchFamily="34" charset="-120"/>
               </a:rPr>
-              <a:t>WEEKS 9–12</a:t>
+              <a:t>ONGOING</a:t>
             </a:r>
             <a:endParaRPr lang="en-US" sz="1000" dirty="0"/>
           </a:p>
@@ -8360,7 +8336,7 @@
                 <a:ea typeface="Cambria" pitchFamily="34" charset="-122"/>
                 <a:cs typeface="Cambria" pitchFamily="34" charset="-120"/>
               </a:rPr>
-              <a:t>Scale</a:t>
+              <a:t>Stay Market-Ready</a:t>
             </a:r>
             <a:endParaRPr lang="en-US" sz="1650" dirty="0"/>
           </a:p>
@@ -8406,7 +8382,7 @@
                 <a:ea typeface="Calibri" pitchFamily="34" charset="-122"/>
                 <a:cs typeface="Calibri" pitchFamily="34" charset="-120"/>
               </a:rPr>
-              <a:t>Analyze CPL, QL &amp; ROI</a:t>
+              <a:t>Adjust to real-estate cost shifts</a:t>
             </a:r>
             <a:endParaRPr lang="en-US" sz="1050" dirty="0"/>
           </a:p>
@@ -8430,7 +8406,7 @@
                 <a:ea typeface="Calibri" pitchFamily="34" charset="-122"/>
                 <a:cs typeface="Calibri" pitchFamily="34" charset="-120"/>
               </a:rPr>
-              <a:t>Optimize campaigns</a:t>
+              <a:t>Keep CPL efficient</a:t>
             </a:r>
             <a:endParaRPr lang="en-US" sz="1050" dirty="0"/>
           </a:p>
@@ -8454,7 +8430,7 @@
                 <a:ea typeface="Calibri" pitchFamily="34" charset="-122"/>
                 <a:cs typeface="Calibri" pitchFamily="34" charset="-120"/>
               </a:rPr>
-              <a:t>Scale winning pages</a:t>
+              <a:t>Attract customers consistently</a:t>
             </a:r>
             <a:endParaRPr lang="en-US" sz="1050" dirty="0"/>
           </a:p>
@@ -8478,7 +8454,7 @@
                 <a:ea typeface="Calibri" pitchFamily="34" charset="-122"/>
                 <a:cs typeface="Calibri" pitchFamily="34" charset="-120"/>
               </a:rPr>
-              <a:t>Next 6-month growth plan</a:t>
+              <a:t>Scale what works, cut the rest</a:t>
             </a:r>
             <a:endParaRPr lang="en-US" sz="1050" dirty="0"/>
           </a:p>

</xml_diff>